<commit_message>
Polish project documentation and presentation for portfolio publication
</commit_message>
<xml_diff>
--- a/reports/slides/midterm_v1.pptx
+++ b/reports/slides/midterm_v1.pptx
@@ -2,20 +2,20 @@
 <file path=ppt/presentation.xml><?xml version="1.0" encoding="utf-8"?>
 <p:presentation xmlns:p="http://schemas.openxmlformats.org/presentationml/2006/main">
   <p:sldMasterIdLst>
-    <p:sldMasterId xmlns:r="http://schemas.openxmlformats.org/officeDocument/2006/relationships" id="2147483648" r:id="Re5f7f6c1f7cc4d00"/>
+    <p:sldMasterId xmlns:r="http://schemas.openxmlformats.org/officeDocument/2006/relationships" id="2147483648" r:id="R66ea8ea1fe7b4a1f"/>
   </p:sldMasterIdLst>
   <p:notesMasterIdLst>
-    <p:notesMasterId xmlns:r="http://schemas.openxmlformats.org/officeDocument/2006/relationships" r:id="R2ae463347c6947f3"/>
+    <p:notesMasterId xmlns:r="http://schemas.openxmlformats.org/officeDocument/2006/relationships" r:id="R60056ad531df4f17"/>
   </p:notesMasterIdLst>
   <p:sldIdLst>
-    <p:sldId xmlns:r="http://schemas.openxmlformats.org/officeDocument/2006/relationships" id="256" r:id="R6389f6be94ef4162"/>
-    <p:sldId xmlns:r="http://schemas.openxmlformats.org/officeDocument/2006/relationships" id="257" r:id="Red37845123f24295"/>
-    <p:sldId xmlns:r="http://schemas.openxmlformats.org/officeDocument/2006/relationships" id="258" r:id="R3beb92ecc3494fe5"/>
-    <p:sldId xmlns:r="http://schemas.openxmlformats.org/officeDocument/2006/relationships" id="259" r:id="Reb55dc5b7e9f46d7"/>
-    <p:sldId xmlns:r="http://schemas.openxmlformats.org/officeDocument/2006/relationships" id="260" r:id="Rb4f908d4e3064514"/>
-    <p:sldId xmlns:r="http://schemas.openxmlformats.org/officeDocument/2006/relationships" id="261" r:id="R68e2ea2d52a94b38"/>
-    <p:sldId xmlns:r="http://schemas.openxmlformats.org/officeDocument/2006/relationships" id="262" r:id="Rd067edf558b94568"/>
-    <p:sldId xmlns:r="http://schemas.openxmlformats.org/officeDocument/2006/relationships" id="263" r:id="R62994fd86d6c4ca3"/>
+    <p:sldId xmlns:r="http://schemas.openxmlformats.org/officeDocument/2006/relationships" id="256" r:id="Rc2e2df561e9747a0"/>
+    <p:sldId xmlns:r="http://schemas.openxmlformats.org/officeDocument/2006/relationships" id="257" r:id="Re613d93f38724b40"/>
+    <p:sldId xmlns:r="http://schemas.openxmlformats.org/officeDocument/2006/relationships" id="258" r:id="R214434b53b874d85"/>
+    <p:sldId xmlns:r="http://schemas.openxmlformats.org/officeDocument/2006/relationships" id="259" r:id="R58b5944b391849a0"/>
+    <p:sldId xmlns:r="http://schemas.openxmlformats.org/officeDocument/2006/relationships" id="260" r:id="R8fd3366a271544ef"/>
+    <p:sldId xmlns:r="http://schemas.openxmlformats.org/officeDocument/2006/relationships" id="261" r:id="Rb2d6d01fde9d4a8c"/>
+    <p:sldId xmlns:r="http://schemas.openxmlformats.org/officeDocument/2006/relationships" id="262" r:id="R90b740b49f594257"/>
+    <p:sldId xmlns:r="http://schemas.openxmlformats.org/officeDocument/2006/relationships" id="263" r:id="R3c904a5f19074f6d"/>
   </p:sldIdLst>
   <p:sldSz cx="12192000" cy="6858000"/>
   <p:notesSz cx="6858000" cy="9144000"/>
@@ -1179,7 +1179,7 @@
           </a:p>
           <a:p xmlns:a="http://schemas.openxmlformats.org/drawingml/2006/main">
             <a:r>
-              <a:t>The selected model achieves a test MAE of 0.714 litres per one hundred kilometres on this saved benchmark. It improves on the median baseline, but we should interpret that result within the collection and evaluation limits. EPA estimates differ from an individual driver’s realised consumption, and the original combined miles-per-gallon field is rounded. The bounded catalogue sample has unequal inclusion probabilities and no sales weighting. The grouped protocol examines unseen vehicle families within the sampled years rather than predicting future model years.  At Endterm we plan ensemble tuning through grouped training validation, descriptive clustering and dimensionality reduction, and a neural network. At Final we plan controlled comparisons of structured features with model names and engine description text on the same split, followed by a local prediction application. Codex assisted with code, collection and analysis artifacts, documentation and presentation drafts. This is an AI capability demonstration rather than an actual course submission. The user requested simulated team roles: Nikita owns collection and data preparation; Bakyt owns modeling, analysis and presentation. The automated implementation is separately recorded in the AI log.</a:t>
+              <a:t>The selected model achieves a test MAE of 0.714 litres per one hundred kilometres on this saved benchmark. It improves on the median baseline, but we should interpret that result within the collection and evaluation limits. EPA estimates differ from an individual driver’s realised consumption, and the original combined miles-per-gallon field is rounded. The bounded catalogue sample has unequal inclusion probabilities and no sales weighting. The grouped protocol examines unseen vehicle families within the sampled years rather than predicting future model years.  At Endterm we plan ensemble tuning through grouped training validation, descriptive clustering and dimensionality reduction, and a neural network. At Final we plan controlled comparisons of structured features with model names and engine description text on the same split, followed by a local prediction application. Project areas: Nikita, data collection. Bakytzhan, modeling and analysis. OpenAI Codex assisted with code, collection and analysis artifacts, documentation and presentation drafts. AI assistance is documented in docs/CONTRIBUTIONS.md.</a:t>
             </a:r>
           </a:p>
           <a:p xmlns:a="http://schemas.openxmlformats.org/drawingml/2006/main">
@@ -1302,6 +1302,7 @@
                 <a:spcPts val="0"/>
               </a:spcAft>
               <a:buNone/>
+              <a:defRPr/>
             </a:lvl1pPr>
             <a:lvl2pPr marL="0" indent="0">
               <a:lnSpc>
@@ -1314,6 +1315,7 @@
                 <a:spcPts val="0"/>
               </a:spcAft>
               <a:buNone/>
+              <a:defRPr/>
             </a:lvl2pPr>
             <a:lvl3pPr marL="0" indent="0">
               <a:lnSpc>
@@ -1326,6 +1328,7 @@
                 <a:spcPts val="0"/>
               </a:spcAft>
               <a:buNone/>
+              <a:defRPr/>
             </a:lvl3pPr>
             <a:lvl4pPr marL="0" indent="0">
               <a:lnSpc>
@@ -1338,6 +1341,7 @@
                 <a:spcPts val="0"/>
               </a:spcAft>
               <a:buNone/>
+              <a:defRPr/>
             </a:lvl4pPr>
             <a:lvl5pPr marL="0" indent="0">
               <a:lnSpc>
@@ -1350,6 +1354,7 @@
                 <a:spcPts val="0"/>
               </a:spcAft>
               <a:buNone/>
+              <a:defRPr/>
             </a:lvl5pPr>
             <a:lvl6pPr marL="0" indent="0">
               <a:lnSpc>
@@ -1362,6 +1367,7 @@
                 <a:spcPts val="0"/>
               </a:spcAft>
               <a:buNone/>
+              <a:defRPr/>
             </a:lvl6pPr>
             <a:lvl7pPr marL="0" indent="0">
               <a:lnSpc>
@@ -1374,6 +1380,7 @@
                 <a:spcPts val="0"/>
               </a:spcAft>
               <a:buNone/>
+              <a:defRPr/>
             </a:lvl7pPr>
             <a:lvl8pPr marL="0" indent="0">
               <a:lnSpc>
@@ -1386,6 +1393,7 @@
                 <a:spcPts val="0"/>
               </a:spcAft>
               <a:buNone/>
+              <a:defRPr/>
             </a:lvl8pPr>
             <a:lvl9pPr marL="0" indent="0">
               <a:lnSpc>
@@ -1398,6 +1406,7 @@
                 <a:spcPts val="0"/>
               </a:spcAft>
               <a:buNone/>
+              <a:defRPr/>
             </a:lvl9pPr>
           </a:lstStyle>
           <a:p xmlns:a="http://schemas.openxmlformats.org/drawingml/2006/main"/>
@@ -1459,6 +1468,7 @@
                 <a:spcPts val="0"/>
               </a:spcAft>
               <a:buNone/>
+              <a:defRPr/>
             </a:lvl1pPr>
             <a:lvl2pPr marL="0" indent="0">
               <a:lnSpc>
@@ -1471,6 +1481,7 @@
                 <a:spcPts val="0"/>
               </a:spcAft>
               <a:buNone/>
+              <a:defRPr/>
             </a:lvl2pPr>
             <a:lvl3pPr marL="0" indent="0">
               <a:lnSpc>
@@ -1483,6 +1494,7 @@
                 <a:spcPts val="0"/>
               </a:spcAft>
               <a:buNone/>
+              <a:defRPr/>
             </a:lvl3pPr>
             <a:lvl4pPr marL="0" indent="0">
               <a:lnSpc>
@@ -1495,6 +1507,7 @@
                 <a:spcPts val="0"/>
               </a:spcAft>
               <a:buNone/>
+              <a:defRPr/>
             </a:lvl4pPr>
             <a:lvl5pPr marL="0" indent="0">
               <a:lnSpc>
@@ -1507,6 +1520,7 @@
                 <a:spcPts val="0"/>
               </a:spcAft>
               <a:buNone/>
+              <a:defRPr/>
             </a:lvl5pPr>
             <a:lvl6pPr marL="0" indent="0">
               <a:lnSpc>
@@ -1519,6 +1533,7 @@
                 <a:spcPts val="0"/>
               </a:spcAft>
               <a:buNone/>
+              <a:defRPr/>
             </a:lvl6pPr>
             <a:lvl7pPr marL="0" indent="0">
               <a:lnSpc>
@@ -1531,6 +1546,7 @@
                 <a:spcPts val="0"/>
               </a:spcAft>
               <a:buNone/>
+              <a:defRPr/>
             </a:lvl7pPr>
             <a:lvl8pPr marL="0" indent="0">
               <a:lnSpc>
@@ -1543,6 +1559,7 @@
                 <a:spcPts val="0"/>
               </a:spcAft>
               <a:buNone/>
+              <a:defRPr/>
             </a:lvl8pPr>
             <a:lvl9pPr marL="0" indent="0">
               <a:lnSpc>
@@ -1555,6 +1572,7 @@
                 <a:spcPts val="0"/>
               </a:spcAft>
               <a:buNone/>
+              <a:defRPr/>
             </a:lvl9pPr>
           </a:lstStyle>
           <a:p xmlns:a="http://schemas.openxmlformats.org/drawingml/2006/main"/>
@@ -1633,6 +1651,7 @@
                 <a:spcPts val="0"/>
               </a:spcAft>
               <a:buNone/>
+              <a:defRPr/>
             </a:lvl1pPr>
             <a:lvl2pPr marL="0" indent="0">
               <a:lnSpc>
@@ -1645,6 +1664,7 @@
                 <a:spcPts val="0"/>
               </a:spcAft>
               <a:buNone/>
+              <a:defRPr/>
             </a:lvl2pPr>
             <a:lvl3pPr marL="0" indent="0">
               <a:lnSpc>
@@ -1657,6 +1677,7 @@
                 <a:spcPts val="0"/>
               </a:spcAft>
               <a:buNone/>
+              <a:defRPr/>
             </a:lvl3pPr>
             <a:lvl4pPr marL="0" indent="0">
               <a:lnSpc>
@@ -1669,6 +1690,7 @@
                 <a:spcPts val="0"/>
               </a:spcAft>
               <a:buNone/>
+              <a:defRPr/>
             </a:lvl4pPr>
             <a:lvl5pPr marL="0" indent="0">
               <a:lnSpc>
@@ -1681,6 +1703,7 @@
                 <a:spcPts val="0"/>
               </a:spcAft>
               <a:buNone/>
+              <a:defRPr/>
             </a:lvl5pPr>
             <a:lvl6pPr marL="0" indent="0">
               <a:lnSpc>
@@ -1693,6 +1716,7 @@
                 <a:spcPts val="0"/>
               </a:spcAft>
               <a:buNone/>
+              <a:defRPr/>
             </a:lvl6pPr>
             <a:lvl7pPr marL="0" indent="0">
               <a:lnSpc>
@@ -1705,6 +1729,7 @@
                 <a:spcPts val="0"/>
               </a:spcAft>
               <a:buNone/>
+              <a:defRPr/>
             </a:lvl7pPr>
             <a:lvl8pPr marL="0" indent="0">
               <a:lnSpc>
@@ -1717,6 +1742,7 @@
                 <a:spcPts val="0"/>
               </a:spcAft>
               <a:buNone/>
+              <a:defRPr/>
             </a:lvl8pPr>
             <a:lvl9pPr marL="0" indent="0">
               <a:lnSpc>
@@ -1729,6 +1755,7 @@
                 <a:spcPts val="0"/>
               </a:spcAft>
               <a:buNone/>
+              <a:defRPr/>
             </a:lvl9pPr>
           </a:lstStyle>
           <a:p xmlns:a="http://schemas.openxmlformats.org/drawingml/2006/main"/>
@@ -1807,6 +1834,7 @@
                 <a:spcPts val="0"/>
               </a:spcAft>
               <a:buNone/>
+              <a:defRPr/>
             </a:lvl1pPr>
             <a:lvl2pPr marL="0" indent="0">
               <a:lnSpc>
@@ -1819,6 +1847,7 @@
                 <a:spcPts val="0"/>
               </a:spcAft>
               <a:buNone/>
+              <a:defRPr/>
             </a:lvl2pPr>
             <a:lvl3pPr marL="0" indent="0">
               <a:lnSpc>
@@ -1831,6 +1860,7 @@
                 <a:spcPts val="0"/>
               </a:spcAft>
               <a:buNone/>
+              <a:defRPr/>
             </a:lvl3pPr>
             <a:lvl4pPr marL="0" indent="0">
               <a:lnSpc>
@@ -1843,6 +1873,7 @@
                 <a:spcPts val="0"/>
               </a:spcAft>
               <a:buNone/>
+              <a:defRPr/>
             </a:lvl4pPr>
             <a:lvl5pPr marL="0" indent="0">
               <a:lnSpc>
@@ -1855,6 +1886,7 @@
                 <a:spcPts val="0"/>
               </a:spcAft>
               <a:buNone/>
+              <a:defRPr/>
             </a:lvl5pPr>
             <a:lvl6pPr marL="0" indent="0">
               <a:lnSpc>
@@ -1867,6 +1899,7 @@
                 <a:spcPts val="0"/>
               </a:spcAft>
               <a:buNone/>
+              <a:defRPr/>
             </a:lvl6pPr>
             <a:lvl7pPr marL="0" indent="0">
               <a:lnSpc>
@@ -1879,6 +1912,7 @@
                 <a:spcPts val="0"/>
               </a:spcAft>
               <a:buNone/>
+              <a:defRPr/>
             </a:lvl7pPr>
             <a:lvl8pPr marL="0" indent="0">
               <a:lnSpc>
@@ -1891,6 +1925,7 @@
                 <a:spcPts val="0"/>
               </a:spcAft>
               <a:buNone/>
+              <a:defRPr/>
             </a:lvl8pPr>
             <a:lvl9pPr marL="0" indent="0">
               <a:lnSpc>
@@ -1903,6 +1938,7 @@
                 <a:spcPts val="0"/>
               </a:spcAft>
               <a:buNone/>
+              <a:defRPr/>
             </a:lvl9pPr>
           </a:lstStyle>
           <a:p xmlns:a="http://schemas.openxmlformats.org/drawingml/2006/main"/>
@@ -1964,6 +2000,7 @@
                 <a:spcPts val="1200"/>
               </a:spcAft>
               <a:buChar char="•"/>
+              <a:defRPr/>
             </a:lvl1pPr>
             <a:lvl2pPr marL="533400" indent="-228600">
               <a:lnSpc>
@@ -1976,6 +2013,7 @@
                 <a:spcPts val="1200"/>
               </a:spcAft>
               <a:buChar char="•"/>
+              <a:defRPr/>
             </a:lvl2pPr>
             <a:lvl3pPr marL="838200" indent="-228600">
               <a:lnSpc>
@@ -1988,6 +2026,7 @@
                 <a:spcPts val="1200"/>
               </a:spcAft>
               <a:buChar char="•"/>
+              <a:defRPr/>
             </a:lvl3pPr>
             <a:lvl4pPr marL="1143000" indent="-228600">
               <a:lnSpc>
@@ -2000,6 +2039,7 @@
                 <a:spcPts val="1200"/>
               </a:spcAft>
               <a:buChar char="•"/>
+              <a:defRPr/>
             </a:lvl4pPr>
             <a:lvl5pPr marL="1447800" indent="-228600">
               <a:lnSpc>
@@ -2012,6 +2052,7 @@
                 <a:spcPts val="1200"/>
               </a:spcAft>
               <a:buChar char="•"/>
+              <a:defRPr/>
             </a:lvl5pPr>
             <a:lvl6pPr marL="1752600" indent="-228600">
               <a:lnSpc>
@@ -2024,6 +2065,7 @@
                 <a:spcPts val="1200"/>
               </a:spcAft>
               <a:buChar char="•"/>
+              <a:defRPr/>
             </a:lvl6pPr>
             <a:lvl7pPr marL="2057400" indent="-228600">
               <a:lnSpc>
@@ -2036,6 +2078,7 @@
                 <a:spcPts val="1200"/>
               </a:spcAft>
               <a:buChar char="•"/>
+              <a:defRPr/>
             </a:lvl7pPr>
             <a:lvl8pPr marL="2362200" indent="-228600">
               <a:lnSpc>
@@ -2048,6 +2091,7 @@
                 <a:spcPts val="1200"/>
               </a:spcAft>
               <a:buChar char="•"/>
+              <a:defRPr/>
             </a:lvl8pPr>
             <a:lvl9pPr marL="2667000" indent="-228600">
               <a:lnSpc>
@@ -2060,6 +2104,7 @@
                 <a:spcPts val="1200"/>
               </a:spcAft>
               <a:buChar char="•"/>
+              <a:defRPr/>
             </a:lvl9pPr>
           </a:lstStyle>
           <a:p xmlns:a="http://schemas.openxmlformats.org/drawingml/2006/main"/>
@@ -2138,6 +2183,7 @@
                 <a:spcPts val="0"/>
               </a:spcAft>
               <a:buNone/>
+              <a:defRPr/>
             </a:lvl1pPr>
             <a:lvl2pPr marL="0" indent="0">
               <a:lnSpc>
@@ -2150,6 +2196,7 @@
                 <a:spcPts val="0"/>
               </a:spcAft>
               <a:buNone/>
+              <a:defRPr/>
             </a:lvl2pPr>
             <a:lvl3pPr marL="0" indent="0">
               <a:lnSpc>
@@ -2162,6 +2209,7 @@
                 <a:spcPts val="0"/>
               </a:spcAft>
               <a:buNone/>
+              <a:defRPr/>
             </a:lvl3pPr>
             <a:lvl4pPr marL="0" indent="0">
               <a:lnSpc>
@@ -2174,6 +2222,7 @@
                 <a:spcPts val="0"/>
               </a:spcAft>
               <a:buNone/>
+              <a:defRPr/>
             </a:lvl4pPr>
             <a:lvl5pPr marL="0" indent="0">
               <a:lnSpc>
@@ -2186,6 +2235,7 @@
                 <a:spcPts val="0"/>
               </a:spcAft>
               <a:buNone/>
+              <a:defRPr/>
             </a:lvl5pPr>
             <a:lvl6pPr marL="0" indent="0">
               <a:lnSpc>
@@ -2198,6 +2248,7 @@
                 <a:spcPts val="0"/>
               </a:spcAft>
               <a:buNone/>
+              <a:defRPr/>
             </a:lvl6pPr>
             <a:lvl7pPr marL="0" indent="0">
               <a:lnSpc>
@@ -2210,6 +2261,7 @@
                 <a:spcPts val="0"/>
               </a:spcAft>
               <a:buNone/>
+              <a:defRPr/>
             </a:lvl7pPr>
             <a:lvl8pPr marL="0" indent="0">
               <a:lnSpc>
@@ -2222,6 +2274,7 @@
                 <a:spcPts val="0"/>
               </a:spcAft>
               <a:buNone/>
+              <a:defRPr/>
             </a:lvl8pPr>
             <a:lvl9pPr marL="0" indent="0">
               <a:lnSpc>
@@ -2234,6 +2287,7 @@
                 <a:spcPts val="0"/>
               </a:spcAft>
               <a:buNone/>
+              <a:defRPr/>
             </a:lvl9pPr>
           </a:lstStyle>
           <a:p xmlns:a="http://schemas.openxmlformats.org/drawingml/2006/main"/>
@@ -2295,6 +2349,7 @@
                 <a:spcPts val="1200"/>
               </a:spcAft>
               <a:buChar char="•"/>
+              <a:defRPr/>
             </a:lvl1pPr>
             <a:lvl2pPr marL="533400" indent="-228600">
               <a:lnSpc>
@@ -2307,6 +2362,7 @@
                 <a:spcPts val="1200"/>
               </a:spcAft>
               <a:buChar char="•"/>
+              <a:defRPr/>
             </a:lvl2pPr>
             <a:lvl3pPr marL="838200" indent="-228600">
               <a:lnSpc>
@@ -2319,6 +2375,7 @@
                 <a:spcPts val="1200"/>
               </a:spcAft>
               <a:buChar char="•"/>
+              <a:defRPr/>
             </a:lvl3pPr>
             <a:lvl4pPr marL="1143000" indent="-228600">
               <a:lnSpc>
@@ -2331,6 +2388,7 @@
                 <a:spcPts val="1200"/>
               </a:spcAft>
               <a:buChar char="•"/>
+              <a:defRPr/>
             </a:lvl4pPr>
             <a:lvl5pPr marL="1447800" indent="-228600">
               <a:lnSpc>
@@ -2343,6 +2401,7 @@
                 <a:spcPts val="1200"/>
               </a:spcAft>
               <a:buChar char="•"/>
+              <a:defRPr/>
             </a:lvl5pPr>
             <a:lvl6pPr marL="1752600" indent="-228600">
               <a:lnSpc>
@@ -2355,6 +2414,7 @@
                 <a:spcPts val="1200"/>
               </a:spcAft>
               <a:buChar char="•"/>
+              <a:defRPr/>
             </a:lvl6pPr>
             <a:lvl7pPr marL="2057400" indent="-228600">
               <a:lnSpc>
@@ -2367,6 +2427,7 @@
                 <a:spcPts val="1200"/>
               </a:spcAft>
               <a:buChar char="•"/>
+              <a:defRPr/>
             </a:lvl7pPr>
             <a:lvl8pPr marL="2362200" indent="-228600">
               <a:lnSpc>
@@ -2379,6 +2440,7 @@
                 <a:spcPts val="1200"/>
               </a:spcAft>
               <a:buChar char="•"/>
+              <a:defRPr/>
             </a:lvl8pPr>
             <a:lvl9pPr marL="2667000" indent="-228600">
               <a:lnSpc>
@@ -2391,6 +2453,7 @@
                 <a:spcPts val="1200"/>
               </a:spcAft>
               <a:buChar char="•"/>
+              <a:defRPr/>
             </a:lvl9pPr>
           </a:lstStyle>
           <a:p xmlns:a="http://schemas.openxmlformats.org/drawingml/2006/main"/>
@@ -2452,6 +2515,7 @@
                 <a:spcPts val="1200"/>
               </a:spcAft>
               <a:buChar char="•"/>
+              <a:defRPr/>
             </a:lvl1pPr>
             <a:lvl2pPr marL="533400" indent="-228600">
               <a:lnSpc>
@@ -2464,6 +2528,7 @@
                 <a:spcPts val="1200"/>
               </a:spcAft>
               <a:buChar char="•"/>
+              <a:defRPr/>
             </a:lvl2pPr>
             <a:lvl3pPr marL="838200" indent="-228600">
               <a:lnSpc>
@@ -2476,6 +2541,7 @@
                 <a:spcPts val="1200"/>
               </a:spcAft>
               <a:buChar char="•"/>
+              <a:defRPr/>
             </a:lvl3pPr>
             <a:lvl4pPr marL="1143000" indent="-228600">
               <a:lnSpc>
@@ -2488,6 +2554,7 @@
                 <a:spcPts val="1200"/>
               </a:spcAft>
               <a:buChar char="•"/>
+              <a:defRPr/>
             </a:lvl4pPr>
             <a:lvl5pPr marL="1447800" indent="-228600">
               <a:lnSpc>
@@ -2500,6 +2567,7 @@
                 <a:spcPts val="1200"/>
               </a:spcAft>
               <a:buChar char="•"/>
+              <a:defRPr/>
             </a:lvl5pPr>
             <a:lvl6pPr marL="1752600" indent="-228600">
               <a:lnSpc>
@@ -2512,6 +2580,7 @@
                 <a:spcPts val="1200"/>
               </a:spcAft>
               <a:buChar char="•"/>
+              <a:defRPr/>
             </a:lvl6pPr>
             <a:lvl7pPr marL="2057400" indent="-228600">
               <a:lnSpc>
@@ -2524,6 +2593,7 @@
                 <a:spcPts val="1200"/>
               </a:spcAft>
               <a:buChar char="•"/>
+              <a:defRPr/>
             </a:lvl7pPr>
             <a:lvl8pPr marL="2362200" indent="-228600">
               <a:lnSpc>
@@ -2536,6 +2606,7 @@
                 <a:spcPts val="1200"/>
               </a:spcAft>
               <a:buChar char="•"/>
+              <a:defRPr/>
             </a:lvl8pPr>
             <a:lvl9pPr marL="2667000" indent="-228600">
               <a:lnSpc>
@@ -2548,6 +2619,7 @@
                 <a:spcPts val="1200"/>
               </a:spcAft>
               <a:buChar char="•"/>
+              <a:defRPr/>
             </a:lvl9pPr>
           </a:lstStyle>
           <a:p xmlns:a="http://schemas.openxmlformats.org/drawingml/2006/main"/>
@@ -2626,6 +2698,7 @@
                 <a:spcPts val="0"/>
               </a:spcAft>
               <a:buNone/>
+              <a:defRPr/>
             </a:lvl1pPr>
             <a:lvl2pPr marL="0" indent="0">
               <a:lnSpc>
@@ -2638,6 +2711,7 @@
                 <a:spcPts val="0"/>
               </a:spcAft>
               <a:buNone/>
+              <a:defRPr/>
             </a:lvl2pPr>
             <a:lvl3pPr marL="0" indent="0">
               <a:lnSpc>
@@ -2650,6 +2724,7 @@
                 <a:spcPts val="0"/>
               </a:spcAft>
               <a:buNone/>
+              <a:defRPr/>
             </a:lvl3pPr>
             <a:lvl4pPr marL="0" indent="0">
               <a:lnSpc>
@@ -2662,6 +2737,7 @@
                 <a:spcPts val="0"/>
               </a:spcAft>
               <a:buNone/>
+              <a:defRPr/>
             </a:lvl4pPr>
             <a:lvl5pPr marL="0" indent="0">
               <a:lnSpc>
@@ -2674,6 +2750,7 @@
                 <a:spcPts val="0"/>
               </a:spcAft>
               <a:buNone/>
+              <a:defRPr/>
             </a:lvl5pPr>
             <a:lvl6pPr marL="0" indent="0">
               <a:lnSpc>
@@ -2686,6 +2763,7 @@
                 <a:spcPts val="0"/>
               </a:spcAft>
               <a:buNone/>
+              <a:defRPr/>
             </a:lvl6pPr>
             <a:lvl7pPr marL="0" indent="0">
               <a:lnSpc>
@@ -2698,6 +2776,7 @@
                 <a:spcPts val="0"/>
               </a:spcAft>
               <a:buNone/>
+              <a:defRPr/>
             </a:lvl7pPr>
             <a:lvl8pPr marL="0" indent="0">
               <a:lnSpc>
@@ -2710,6 +2789,7 @@
                 <a:spcPts val="0"/>
               </a:spcAft>
               <a:buNone/>
+              <a:defRPr/>
             </a:lvl8pPr>
             <a:lvl9pPr marL="0" indent="0">
               <a:lnSpc>
@@ -2722,6 +2802,7 @@
                 <a:spcPts val="0"/>
               </a:spcAft>
               <a:buNone/>
+              <a:defRPr/>
             </a:lvl9pPr>
           </a:lstStyle>
           <a:p xmlns:a="http://schemas.openxmlformats.org/drawingml/2006/main"/>
@@ -2783,6 +2864,7 @@
                 <a:spcPts val="1200"/>
               </a:spcAft>
               <a:buChar char="•"/>
+              <a:defRPr/>
             </a:lvl1pPr>
             <a:lvl2pPr marL="533400" indent="-228600">
               <a:lnSpc>
@@ -2795,6 +2877,7 @@
                 <a:spcPts val="1200"/>
               </a:spcAft>
               <a:buChar char="•"/>
+              <a:defRPr/>
             </a:lvl2pPr>
             <a:lvl3pPr marL="838200" indent="-228600">
               <a:lnSpc>
@@ -2807,6 +2890,7 @@
                 <a:spcPts val="1200"/>
               </a:spcAft>
               <a:buChar char="•"/>
+              <a:defRPr/>
             </a:lvl3pPr>
             <a:lvl4pPr marL="1143000" indent="-228600">
               <a:lnSpc>
@@ -2819,6 +2903,7 @@
                 <a:spcPts val="1200"/>
               </a:spcAft>
               <a:buChar char="•"/>
+              <a:defRPr/>
             </a:lvl4pPr>
             <a:lvl5pPr marL="1447800" indent="-228600">
               <a:lnSpc>
@@ -2831,6 +2916,7 @@
                 <a:spcPts val="1200"/>
               </a:spcAft>
               <a:buChar char="•"/>
+              <a:defRPr/>
             </a:lvl5pPr>
             <a:lvl6pPr marL="1752600" indent="-228600">
               <a:lnSpc>
@@ -2843,6 +2929,7 @@
                 <a:spcPts val="1200"/>
               </a:spcAft>
               <a:buChar char="•"/>
+              <a:defRPr/>
             </a:lvl6pPr>
             <a:lvl7pPr marL="2057400" indent="-228600">
               <a:lnSpc>
@@ -2855,6 +2942,7 @@
                 <a:spcPts val="1200"/>
               </a:spcAft>
               <a:buChar char="•"/>
+              <a:defRPr/>
             </a:lvl7pPr>
             <a:lvl8pPr marL="2362200" indent="-228600">
               <a:lnSpc>
@@ -2867,6 +2955,7 @@
                 <a:spcPts val="1200"/>
               </a:spcAft>
               <a:buChar char="•"/>
+              <a:defRPr/>
             </a:lvl8pPr>
             <a:lvl9pPr marL="2667000" indent="-228600">
               <a:lnSpc>
@@ -2879,6 +2968,7 @@
                 <a:spcPts val="1200"/>
               </a:spcAft>
               <a:buChar char="•"/>
+              <a:defRPr/>
             </a:lvl9pPr>
           </a:lstStyle>
           <a:p xmlns:a="http://schemas.openxmlformats.org/drawingml/2006/main"/>
@@ -2927,12 +3017,12 @@
   </p:cSld>
   <p:clrMap bg1="lt1" tx1="dk1" bg2="lt2" tx2="dk2" accent1="accent1" accent2="accent2" accent3="accent3" accent4="accent4" accent5="accent5" accent6="accent6" hlink="hlink" folHlink="folHlink"/>
   <p:sldLayoutIdLst>
-    <p:sldLayoutId xmlns:r="http://schemas.openxmlformats.org/officeDocument/2006/relationships" id="2147483649" r:id="Rad38ce8721604d73"/>
-    <p:sldLayoutId xmlns:r="http://schemas.openxmlformats.org/officeDocument/2006/relationships" id="2147483650" r:id="Re3d52d5a3d0b4981"/>
-    <p:sldLayoutId xmlns:r="http://schemas.openxmlformats.org/officeDocument/2006/relationships" id="2147483651" r:id="R45c8524d78cb4786"/>
-    <p:sldLayoutId xmlns:r="http://schemas.openxmlformats.org/officeDocument/2006/relationships" id="2147483652" r:id="Rf13d816319f74bb7"/>
-    <p:sldLayoutId xmlns:r="http://schemas.openxmlformats.org/officeDocument/2006/relationships" id="2147483653" r:id="Rc7be7c41acd54f49"/>
-    <p:sldLayoutId xmlns:r="http://schemas.openxmlformats.org/officeDocument/2006/relationships" id="2147483654" r:id="R2cc8464387884f12"/>
+    <p:sldLayoutId xmlns:r="http://schemas.openxmlformats.org/officeDocument/2006/relationships" id="2147483649" r:id="Rc95a79fdda6849a5"/>
+    <p:sldLayoutId xmlns:r="http://schemas.openxmlformats.org/officeDocument/2006/relationships" id="2147483650" r:id="R5e6d0f8da2ff4324"/>
+    <p:sldLayoutId xmlns:r="http://schemas.openxmlformats.org/officeDocument/2006/relationships" id="2147483651" r:id="Rc00e4b0a14c34ee9"/>
+    <p:sldLayoutId xmlns:r="http://schemas.openxmlformats.org/officeDocument/2006/relationships" id="2147483652" r:id="R1b7b94c402c545e7"/>
+    <p:sldLayoutId xmlns:r="http://schemas.openxmlformats.org/officeDocument/2006/relationships" id="2147483653" r:id="R7c40084b22024674"/>
+    <p:sldLayoutId xmlns:r="http://schemas.openxmlformats.org/officeDocument/2006/relationships" id="2147483654" r:id="R687551fd24264d5d"/>
   </p:sldLayoutIdLst>
   <p:txStyles>
     <p:titleStyle>
@@ -4613,6 +4703,7 @@
           </a:lstStyle>
           <a:p xmlns:a="http://schemas.openxmlformats.org/drawingml/2006/main">
             <a:pPr algn="l">
+              <a:buNone/>
               <a:defRPr sz="4800" b="1">
                 <a:solidFill>
                   <a:srgbClr val="FFFFFF"/>
@@ -4636,6 +4727,7 @@
           </a:p>
           <a:p xmlns:a="http://schemas.openxmlformats.org/drawingml/2006/main">
             <a:pPr algn="l">
+              <a:buNone/>
               <a:defRPr sz="4800" b="1">
                 <a:solidFill>
                   <a:srgbClr val="FFFFFF"/>
@@ -4705,6 +4797,7 @@
           </a:lstStyle>
           <a:p xmlns:a="http://schemas.openxmlformats.org/drawingml/2006/main">
             <a:pPr algn="l">
+              <a:buNone/>
               <a:defRPr sz="2400" b="0">
                 <a:solidFill>
                   <a:srgbClr val="FFFFFF"/>
@@ -4728,6 +4821,7 @@
           </a:p>
           <a:p xmlns:a="http://schemas.openxmlformats.org/drawingml/2006/main">
             <a:pPr algn="l">
+              <a:buNone/>
               <a:defRPr sz="2400" b="0">
                 <a:solidFill>
                   <a:srgbClr val="FFFFFF"/>
@@ -4797,6 +4891,7 @@
           </a:lstStyle>
           <a:p xmlns:a="http://schemas.openxmlformats.org/drawingml/2006/main">
             <a:pPr algn="l">
+              <a:buNone/>
               <a:defRPr sz="1950" b="0">
                 <a:solidFill>
                   <a:srgbClr val="A9CDD7"/>
@@ -4866,6 +4961,7 @@
           </a:lstStyle>
           <a:p xmlns:a="http://schemas.openxmlformats.org/drawingml/2006/main">
             <a:pPr algn="l">
+              <a:buNone/>
               <a:defRPr sz="1875" b="0">
                 <a:solidFill>
                   <a:srgbClr val="FFFFFF"/>
@@ -4889,6 +4985,7 @@
           </a:p>
           <a:p xmlns:a="http://schemas.openxmlformats.org/drawingml/2006/main">
             <a:pPr algn="l">
+              <a:buNone/>
               <a:defRPr sz="1875" b="0">
                 <a:solidFill>
                   <a:srgbClr val="FFFFFF"/>
@@ -4987,6 +5084,7 @@
           </a:lstStyle>
           <a:p xmlns:a="http://schemas.openxmlformats.org/drawingml/2006/main">
             <a:pPr algn="l">
+              <a:buNone/>
               <a:defRPr sz="3300" b="1">
                 <a:solidFill>
                   <a:srgbClr val="102238"/>
@@ -5056,6 +5154,7 @@
           </a:lstStyle>
           <a:p xmlns:a="http://schemas.openxmlformats.org/drawingml/2006/main">
             <a:pPr algn="l">
+              <a:buNone/>
               <a:defRPr sz="1200" b="0">
                 <a:solidFill>
                   <a:srgbClr val="526579"/>
@@ -5125,6 +5224,7 @@
           </a:lstStyle>
           <a:p xmlns:a="http://schemas.openxmlformats.org/drawingml/2006/main">
             <a:pPr algn="r">
+              <a:buNone/>
               <a:defRPr sz="1200" b="0">
                 <a:solidFill>
                   <a:srgbClr val="526579"/>
@@ -5194,6 +5294,7 @@
           </a:lstStyle>
           <a:p xmlns:a="http://schemas.openxmlformats.org/drawingml/2006/main">
             <a:pPr algn="l">
+              <a:buNone/>
               <a:defRPr sz="3150" b="1">
                 <a:solidFill>
                   <a:srgbClr val="102238"/>
@@ -5263,6 +5364,7 @@
           </a:lstStyle>
           <a:p xmlns:a="http://schemas.openxmlformats.org/drawingml/2006/main">
             <a:pPr algn="l">
+              <a:buNone/>
               <a:defRPr sz="2100" b="0">
                 <a:solidFill>
                   <a:srgbClr val="102238"/>
@@ -5332,6 +5434,7 @@
           </a:lstStyle>
           <a:p xmlns:a="http://schemas.openxmlformats.org/drawingml/2006/main">
             <a:pPr algn="l">
+              <a:buNone/>
               <a:defRPr sz="2100" b="0">
                 <a:solidFill>
                   <a:srgbClr val="102238"/>
@@ -5401,6 +5504,7 @@
           </a:lstStyle>
           <a:p xmlns:a="http://schemas.openxmlformats.org/drawingml/2006/main">
             <a:pPr algn="l">
+              <a:buNone/>
               <a:defRPr sz="3150" b="1">
                 <a:solidFill>
                   <a:srgbClr val="087D9A"/>
@@ -5470,6 +5574,7 @@
           </a:lstStyle>
           <a:p xmlns:a="http://schemas.openxmlformats.org/drawingml/2006/main">
             <a:pPr algn="l">
+              <a:buNone/>
               <a:defRPr sz="2025" b="0">
                 <a:solidFill>
                   <a:srgbClr val="102238"/>
@@ -5493,6 +5598,7 @@
           </a:p>
           <a:p xmlns:a="http://schemas.openxmlformats.org/drawingml/2006/main">
             <a:pPr algn="l">
+              <a:buNone/>
               <a:defRPr sz="2025" b="0">
                 <a:solidFill>
                   <a:srgbClr val="102238"/>
@@ -5516,6 +5622,7 @@
           </a:p>
           <a:p xmlns:a="http://schemas.openxmlformats.org/drawingml/2006/main">
             <a:pPr algn="l">
+              <a:buNone/>
               <a:defRPr sz="2025" b="0">
                 <a:solidFill>
                   <a:srgbClr val="102238"/>
@@ -5539,6 +5646,7 @@
           </a:p>
           <a:p xmlns:a="http://schemas.openxmlformats.org/drawingml/2006/main">
             <a:pPr algn="l">
+              <a:buNone/>
               <a:defRPr sz="2025" b="0">
                 <a:solidFill>
                   <a:srgbClr val="102238"/>
@@ -5608,6 +5716,7 @@
           </a:lstStyle>
           <a:p xmlns:a="http://schemas.openxmlformats.org/drawingml/2006/main">
             <a:pPr algn="l">
+              <a:buNone/>
               <a:defRPr sz="1950" b="0">
                 <a:solidFill>
                   <a:srgbClr val="526579"/>
@@ -5631,6 +5740,7 @@
           </a:p>
           <a:p xmlns:a="http://schemas.openxmlformats.org/drawingml/2006/main">
             <a:pPr algn="l">
+              <a:buNone/>
               <a:defRPr sz="1950" b="0">
                 <a:solidFill>
                   <a:srgbClr val="526579"/>
@@ -5700,6 +5810,7 @@
           </a:lstStyle>
           <a:p xmlns:a="http://schemas.openxmlformats.org/drawingml/2006/main">
             <a:pPr algn="l">
+              <a:buNone/>
               <a:defRPr sz="2100" b="1">
                 <a:solidFill>
                   <a:srgbClr val="102238"/>
@@ -5723,6 +5834,7 @@
           </a:p>
           <a:p xmlns:a="http://schemas.openxmlformats.org/drawingml/2006/main">
             <a:pPr algn="l">
+              <a:buNone/>
               <a:defRPr sz="2100" b="1">
                 <a:solidFill>
                   <a:srgbClr val="102238"/>
@@ -5792,6 +5904,7 @@
           </a:lstStyle>
           <a:p xmlns:a="http://schemas.openxmlformats.org/drawingml/2006/main">
             <a:pPr algn="l">
+              <a:buNone/>
               <a:defRPr sz="1725" b="0">
                 <a:solidFill>
                   <a:srgbClr val="526579"/>
@@ -5890,6 +6003,7 @@
           </a:lstStyle>
           <a:p xmlns:a="http://schemas.openxmlformats.org/drawingml/2006/main">
             <a:pPr algn="l">
+              <a:buNone/>
               <a:defRPr sz="3300" b="1">
                 <a:solidFill>
                   <a:srgbClr val="102238"/>
@@ -5959,6 +6073,7 @@
           </a:lstStyle>
           <a:p xmlns:a="http://schemas.openxmlformats.org/drawingml/2006/main">
             <a:pPr algn="l">
+              <a:buNone/>
               <a:defRPr sz="1200" b="0">
                 <a:solidFill>
                   <a:srgbClr val="526579"/>
@@ -6028,6 +6143,7 @@
           </a:lstStyle>
           <a:p xmlns:a="http://schemas.openxmlformats.org/drawingml/2006/main">
             <a:pPr algn="r">
+              <a:buNone/>
               <a:defRPr sz="1200" b="0">
                 <a:solidFill>
                   <a:srgbClr val="526579"/>
@@ -6097,6 +6213,7 @@
           </a:lstStyle>
           <a:p xmlns:a="http://schemas.openxmlformats.org/drawingml/2006/main">
             <a:pPr algn="l">
+              <a:buNone/>
               <a:defRPr sz="1950" b="0">
                 <a:solidFill>
                   <a:srgbClr val="526579"/>
@@ -6120,50 +6237,6 @@
           </a:p>
         </p:txBody>
       </p:sp>
-      <p:graphicFrame>
-        <p:nvGraphicFramePr>
-          <p:cNvPr id="5" name="Chart">
-            <a:extLst xmlns:a="http://schemas.openxmlformats.org/drawingml/2006/main">
-              <a:ext uri="{FF2B5EF4-FFF2-40B4-BE49-F238E27FC236}">
-                <a16:creationId xmlns:a16="http://schemas.microsoft.com/office/drawing/2014/main" id="{4DDDD567-1658-4607-9D11-87583E5DF8B7}"/>
-              </a:ext>
-            </a:extLst>
-          </p:cNvPr>
-          <p:cNvGraphicFramePr/>
-          <p:nvPr/>
-        </p:nvGraphicFramePr>
-        <p:xfrm>
-          <a:off xmlns:a="http://schemas.openxmlformats.org/drawingml/2006/main" x="609600" y="1771650"/>
-          <a:ext xmlns:a="http://schemas.openxmlformats.org/drawingml/2006/main" cx="5238750" cy="3714750"/>
-        </p:xfrm>
-        <a:graphic xmlns:a="http://schemas.openxmlformats.org/drawingml/2006/main">
-          <a:graphicData uri="http://schemas.openxmlformats.org/drawingml/2006/chart">
-            <c:chart xmlns:r="http://schemas.openxmlformats.org/officeDocument/2006/relationships" xmlns:c="http://schemas.openxmlformats.org/drawingml/2006/chart" r:id="R8f91c01cdeb84ded"/>
-          </a:graphicData>
-        </a:graphic>
-      </p:graphicFrame>
-      <p:graphicFrame>
-        <p:nvGraphicFramePr>
-          <p:cNvPr id="6" name="Chart">
-            <a:extLst xmlns:a="http://schemas.openxmlformats.org/drawingml/2006/main">
-              <a:ext uri="{FF2B5EF4-FFF2-40B4-BE49-F238E27FC236}">
-                <a16:creationId xmlns:a16="http://schemas.microsoft.com/office/drawing/2014/main" id="{92322EBE-BE1B-4D1F-98D6-16668AE8857E}"/>
-              </a:ext>
-            </a:extLst>
-          </p:cNvPr>
-          <p:cNvGraphicFramePr/>
-          <p:nvPr/>
-        </p:nvGraphicFramePr>
-        <p:xfrm>
-          <a:off xmlns:a="http://schemas.openxmlformats.org/drawingml/2006/main" x="6324600" y="1771650"/>
-          <a:ext xmlns:a="http://schemas.openxmlformats.org/drawingml/2006/main" cx="5238750" cy="3714750"/>
-        </p:xfrm>
-        <a:graphic xmlns:a="http://schemas.openxmlformats.org/drawingml/2006/main">
-          <a:graphicData uri="http://schemas.openxmlformats.org/drawingml/2006/chart">
-            <c:chart xmlns:r="http://schemas.openxmlformats.org/officeDocument/2006/relationships" xmlns:c="http://schemas.openxmlformats.org/drawingml/2006/chart" r:id="R6561ae3f8d7f4673"/>
-          </a:graphicData>
-        </a:graphic>
-      </p:graphicFrame>
       <p:sp>
         <p:nvSpPr>
           <p:cNvPr id="7" name="eda-interpretation">
@@ -6210,6 +6283,7 @@
           </a:lstStyle>
           <a:p xmlns:a="http://schemas.openxmlformats.org/drawingml/2006/main">
             <a:pPr algn="l">
+              <a:buNone/>
               <a:defRPr sz="1950" b="0">
                 <a:solidFill>
                   <a:srgbClr val="102238"/>
@@ -6233,6 +6307,7 @@
           </a:p>
           <a:p xmlns:a="http://schemas.openxmlformats.org/drawingml/2006/main">
             <a:pPr algn="l">
+              <a:buNone/>
               <a:defRPr sz="1950" b="0">
                 <a:solidFill>
                   <a:srgbClr val="102238"/>
@@ -6256,6 +6331,50 @@
           </a:p>
         </p:txBody>
       </p:sp>
+      <p:graphicFrame>
+        <p:nvGraphicFramePr>
+          <p:cNvPr id="9" name="Chart">
+            <a:extLst xmlns:a="http://schemas.openxmlformats.org/drawingml/2006/main">
+              <a:ext uri="{FF2B5EF4-FFF2-40B4-BE49-F238E27FC236}">
+                <a16:creationId xmlns:a16="http://schemas.microsoft.com/office/drawing/2014/main" id="{0D01B3F4-6050-44C3-90D5-6EF78D118EF1}"/>
+              </a:ext>
+            </a:extLst>
+          </p:cNvPr>
+          <p:cNvGraphicFramePr/>
+          <p:nvPr/>
+        </p:nvGraphicFramePr>
+        <p:xfrm>
+          <a:off xmlns:a="http://schemas.openxmlformats.org/drawingml/2006/main" x="609600" y="1771650"/>
+          <a:ext xmlns:a="http://schemas.openxmlformats.org/drawingml/2006/main" cx="5238750" cy="3714750"/>
+        </p:xfrm>
+        <a:graphic xmlns:a="http://schemas.openxmlformats.org/drawingml/2006/main">
+          <a:graphicData uri="http://schemas.openxmlformats.org/drawingml/2006/chart">
+            <c:chart xmlns:r="http://schemas.openxmlformats.org/officeDocument/2006/relationships" xmlns:c="http://schemas.openxmlformats.org/drawingml/2006/chart" r:id="R3adb5ac1e48c4360"/>
+          </a:graphicData>
+        </a:graphic>
+      </p:graphicFrame>
+      <p:graphicFrame>
+        <p:nvGraphicFramePr>
+          <p:cNvPr id="10" name="Chart">
+            <a:extLst xmlns:a="http://schemas.openxmlformats.org/drawingml/2006/main">
+              <a:ext uri="{FF2B5EF4-FFF2-40B4-BE49-F238E27FC236}">
+                <a16:creationId xmlns:a16="http://schemas.microsoft.com/office/drawing/2014/main" id="{8FD4B6FC-FBDF-404D-A257-8434F03E32DC}"/>
+              </a:ext>
+            </a:extLst>
+          </p:cNvPr>
+          <p:cNvGraphicFramePr/>
+          <p:nvPr/>
+        </p:nvGraphicFramePr>
+        <p:xfrm>
+          <a:off xmlns:a="http://schemas.openxmlformats.org/drawingml/2006/main" x="6324600" y="1771650"/>
+          <a:ext xmlns:a="http://schemas.openxmlformats.org/drawingml/2006/main" cx="5238750" cy="3714750"/>
+        </p:xfrm>
+        <a:graphic xmlns:a="http://schemas.openxmlformats.org/drawingml/2006/main">
+          <a:graphicData uri="http://schemas.openxmlformats.org/drawingml/2006/chart">
+            <c:chart xmlns:r="http://schemas.openxmlformats.org/officeDocument/2006/relationships" xmlns:c="http://schemas.openxmlformats.org/drawingml/2006/chart" r:id="Rbb0642cd76044663"/>
+          </a:graphicData>
+        </a:graphic>
+      </p:graphicFrame>
     </p:spTree>
     <p:extLst>
       <p:ext uri="{BB962C8B-B14F-4D97-AF65-F5344CB8AC3E}">
@@ -6331,6 +6450,7 @@
           </a:lstStyle>
           <a:p xmlns:a="http://schemas.openxmlformats.org/drawingml/2006/main">
             <a:pPr algn="l">
+              <a:buNone/>
               <a:defRPr sz="3300" b="1">
                 <a:solidFill>
                   <a:srgbClr val="102238"/>
@@ -6400,6 +6520,7 @@
           </a:lstStyle>
           <a:p xmlns:a="http://schemas.openxmlformats.org/drawingml/2006/main">
             <a:pPr algn="l">
+              <a:buNone/>
               <a:defRPr sz="1200" b="0">
                 <a:solidFill>
                   <a:srgbClr val="526579"/>
@@ -6469,6 +6590,7 @@
           </a:lstStyle>
           <a:p xmlns:a="http://schemas.openxmlformats.org/drawingml/2006/main">
             <a:pPr algn="r">
+              <a:buNone/>
               <a:defRPr sz="1200" b="0">
                 <a:solidFill>
                   <a:srgbClr val="526579"/>
@@ -6538,6 +6660,7 @@
           </a:lstStyle>
           <a:p xmlns:a="http://schemas.openxmlformats.org/drawingml/2006/main">
             <a:pPr algn="l">
+              <a:buNone/>
               <a:defRPr sz="2400" b="1">
                 <a:solidFill>
                   <a:srgbClr val="102238"/>
@@ -6607,6 +6730,7 @@
           </a:lstStyle>
           <a:p xmlns:a="http://schemas.openxmlformats.org/drawingml/2006/main">
             <a:pPr algn="l">
+              <a:buNone/>
               <a:defRPr sz="2100" b="0">
                 <a:solidFill>
                   <a:srgbClr val="102238"/>
@@ -6630,6 +6754,7 @@
           </a:p>
           <a:p xmlns:a="http://schemas.openxmlformats.org/drawingml/2006/main">
             <a:pPr algn="l">
+              <a:buNone/>
               <a:defRPr sz="2100" b="0">
                 <a:solidFill>
                   <a:srgbClr val="102238"/>
@@ -6699,6 +6824,7 @@
           </a:lstStyle>
           <a:p xmlns:a="http://schemas.openxmlformats.org/drawingml/2006/main">
             <a:pPr algn="l">
+              <a:buNone/>
               <a:defRPr sz="2100" b="0">
                 <a:solidFill>
                   <a:srgbClr val="102238"/>
@@ -6722,6 +6848,7 @@
           </a:p>
           <a:p xmlns:a="http://schemas.openxmlformats.org/drawingml/2006/main">
             <a:pPr algn="l">
+              <a:buNone/>
               <a:defRPr sz="2100" b="0">
                 <a:solidFill>
                   <a:srgbClr val="102238"/>
@@ -6791,6 +6918,7 @@
           </a:lstStyle>
           <a:p xmlns:a="http://schemas.openxmlformats.org/drawingml/2006/main">
             <a:pPr algn="l">
+              <a:buNone/>
               <a:defRPr sz="2400" b="1">
                 <a:solidFill>
                   <a:srgbClr val="102238"/>
@@ -6860,6 +6988,7 @@
           </a:lstStyle>
           <a:p xmlns:a="http://schemas.openxmlformats.org/drawingml/2006/main">
             <a:pPr algn="l">
+              <a:buNone/>
               <a:defRPr sz="2025" b="0">
                 <a:solidFill>
                   <a:srgbClr val="102238"/>
@@ -6883,6 +7012,7 @@
           </a:p>
           <a:p xmlns:a="http://schemas.openxmlformats.org/drawingml/2006/main">
             <a:pPr algn="l">
+              <a:buNone/>
               <a:defRPr sz="2025" b="0">
                 <a:solidFill>
                   <a:srgbClr val="102238"/>
@@ -6911,6 +7041,7 @@
           </a:p>
           <a:p xmlns:a="http://schemas.openxmlformats.org/drawingml/2006/main">
             <a:pPr algn="l">
+              <a:buNone/>
               <a:defRPr sz="2025" b="0">
                 <a:solidFill>
                   <a:srgbClr val="102238"/>
@@ -6934,6 +7065,7 @@
           </a:p>
           <a:p xmlns:a="http://schemas.openxmlformats.org/drawingml/2006/main">
             <a:pPr algn="l">
+              <a:buNone/>
               <a:defRPr sz="2025" b="0">
                 <a:solidFill>
                   <a:srgbClr val="102238"/>
@@ -6962,6 +7094,7 @@
           </a:p>
           <a:p xmlns:a="http://schemas.openxmlformats.org/drawingml/2006/main">
             <a:pPr algn="l">
+              <a:buNone/>
               <a:defRPr sz="2025" b="0">
                 <a:solidFill>
                   <a:srgbClr val="102238"/>
@@ -7031,6 +7164,7 @@
           </a:lstStyle>
           <a:p xmlns:a="http://schemas.openxmlformats.org/drawingml/2006/main">
             <a:pPr algn="l">
+              <a:buNone/>
               <a:defRPr sz="1950" b="0">
                 <a:solidFill>
                   <a:srgbClr val="526579"/>
@@ -7054,6 +7188,7 @@
           </a:p>
           <a:p xmlns:a="http://schemas.openxmlformats.org/drawingml/2006/main">
             <a:pPr algn="l">
+              <a:buNone/>
               <a:defRPr sz="1950" b="0">
                 <a:solidFill>
                   <a:srgbClr val="526579"/>
@@ -7152,6 +7287,7 @@
           </a:lstStyle>
           <a:p xmlns:a="http://schemas.openxmlformats.org/drawingml/2006/main">
             <a:pPr algn="l">
+              <a:buNone/>
               <a:defRPr sz="3300" b="1">
                 <a:solidFill>
                   <a:srgbClr val="102238"/>
@@ -7221,6 +7357,7 @@
           </a:lstStyle>
           <a:p xmlns:a="http://schemas.openxmlformats.org/drawingml/2006/main">
             <a:pPr algn="l">
+              <a:buNone/>
               <a:defRPr sz="1200" b="0">
                 <a:solidFill>
                   <a:srgbClr val="526579"/>
@@ -7290,6 +7427,7 @@
           </a:lstStyle>
           <a:p xmlns:a="http://schemas.openxmlformats.org/drawingml/2006/main">
             <a:pPr algn="r">
+              <a:buNone/>
               <a:defRPr sz="1200" b="0">
                 <a:solidFill>
                   <a:srgbClr val="526579"/>
@@ -7359,6 +7497,7 @@
           </a:lstStyle>
           <a:p xmlns:a="http://schemas.openxmlformats.org/drawingml/2006/main">
             <a:pPr algn="l">
+              <a:buNone/>
               <a:defRPr sz="2775" b="1">
                 <a:solidFill>
                   <a:srgbClr val="102238"/>
@@ -7382,6 +7521,7 @@
           </a:p>
           <a:p xmlns:a="http://schemas.openxmlformats.org/drawingml/2006/main">
             <a:pPr algn="l">
+              <a:buNone/>
               <a:defRPr sz="2775" b="1">
                 <a:solidFill>
                   <a:srgbClr val="102238"/>
@@ -7451,6 +7591,7 @@
           </a:lstStyle>
           <a:p xmlns:a="http://schemas.openxmlformats.org/drawingml/2006/main">
             <a:pPr algn="l">
+              <a:buNone/>
               <a:defRPr sz="2025" b="0">
                 <a:solidFill>
                   <a:srgbClr val="102238"/>
@@ -7474,6 +7615,7 @@
           </a:p>
           <a:p xmlns:a="http://schemas.openxmlformats.org/drawingml/2006/main">
             <a:pPr algn="l">
+              <a:buNone/>
               <a:defRPr sz="2025" b="0">
                 <a:solidFill>
                   <a:srgbClr val="102238"/>
@@ -7502,6 +7644,7 @@
           </a:p>
           <a:p xmlns:a="http://schemas.openxmlformats.org/drawingml/2006/main">
             <a:pPr algn="l">
+              <a:buNone/>
               <a:defRPr sz="2025" b="0">
                 <a:solidFill>
                   <a:srgbClr val="102238"/>
@@ -7525,6 +7668,7 @@
           </a:p>
           <a:p xmlns:a="http://schemas.openxmlformats.org/drawingml/2006/main">
             <a:pPr algn="l">
+              <a:buNone/>
               <a:defRPr sz="2025" b="0">
                 <a:solidFill>
                   <a:srgbClr val="102238"/>
@@ -7594,6 +7738,7 @@
           </a:lstStyle>
           <a:p xmlns:a="http://schemas.openxmlformats.org/drawingml/2006/main">
             <a:pPr algn="l">
+              <a:buNone/>
               <a:defRPr sz="1875" b="0">
                 <a:solidFill>
                   <a:srgbClr val="526579"/>
@@ -7617,6 +7762,7 @@
           </a:p>
           <a:p xmlns:a="http://schemas.openxmlformats.org/drawingml/2006/main">
             <a:pPr algn="l">
+              <a:buNone/>
               <a:defRPr sz="1875" b="0">
                 <a:solidFill>
                   <a:srgbClr val="526579"/>
@@ -7645,7 +7791,7 @@
           <p:cNvPr id="7" name="">
             <a:extLst xmlns:a="http://schemas.openxmlformats.org/drawingml/2006/main">
               <a:ext uri="{FF2B5EF4-FFF2-40B4-BE49-F238E27FC236}">
-                <a16:creationId xmlns:a16="http://schemas.microsoft.com/office/drawing/2014/main" id="{A7EE4B5E-DDAD-4CA1-BD24-278A38AFA74E}"/>
+                <a16:creationId xmlns:a16="http://schemas.microsoft.com/office/drawing/2014/main" id="{1A96BC20-C1A0-4412-9117-B2FC1490C9BC}"/>
               </a:ext>
             </a:extLst>
           </p:cNvPr>
@@ -7964,6 +8110,7 @@
           </a:lstStyle>
           <a:p xmlns:a="http://schemas.openxmlformats.org/drawingml/2006/main">
             <a:pPr algn="l">
+              <a:buNone/>
               <a:defRPr sz="2025" b="0">
                 <a:solidFill>
                   <a:srgbClr val="102238"/>
@@ -7987,6 +8134,7 @@
           </a:p>
           <a:p xmlns:a="http://schemas.openxmlformats.org/drawingml/2006/main">
             <a:pPr algn="l">
+              <a:buNone/>
               <a:defRPr sz="2025" b="0">
                 <a:solidFill>
                   <a:srgbClr val="102238"/>
@@ -8085,6 +8233,7 @@
           </a:lstStyle>
           <a:p xmlns:a="http://schemas.openxmlformats.org/drawingml/2006/main">
             <a:pPr algn="l">
+              <a:buNone/>
               <a:defRPr sz="3300" b="1">
                 <a:solidFill>
                   <a:srgbClr val="102238"/>
@@ -8154,6 +8303,7 @@
           </a:lstStyle>
           <a:p xmlns:a="http://schemas.openxmlformats.org/drawingml/2006/main">
             <a:pPr algn="l">
+              <a:buNone/>
               <a:defRPr sz="1200" b="0">
                 <a:solidFill>
                   <a:srgbClr val="526579"/>
@@ -8223,6 +8373,7 @@
           </a:lstStyle>
           <a:p xmlns:a="http://schemas.openxmlformats.org/drawingml/2006/main">
             <a:pPr algn="r">
+              <a:buNone/>
               <a:defRPr sz="1200" b="0">
                 <a:solidFill>
                   <a:srgbClr val="526579"/>
@@ -8251,7 +8402,7 @@
           <p:cNvPr id="4" name="">
             <a:extLst xmlns:a="http://schemas.openxmlformats.org/drawingml/2006/main">
               <a:ext uri="{FF2B5EF4-FFF2-40B4-BE49-F238E27FC236}">
-                <a16:creationId xmlns:a16="http://schemas.microsoft.com/office/drawing/2014/main" id="{E28FF944-C015-42E3-A794-2AAB9D4EC853}"/>
+                <a16:creationId xmlns:a16="http://schemas.microsoft.com/office/drawing/2014/main" id="{985E2C6B-8C4C-4AA8-8528-FAC016A80D60}"/>
               </a:ext>
             </a:extLst>
           </p:cNvPr>
@@ -9008,28 +9159,6 @@
           </a:graphicData>
         </a:graphic>
       </p:graphicFrame>
-      <p:graphicFrame>
-        <p:nvGraphicFramePr>
-          <p:cNvPr id="5" name="Chart">
-            <a:extLst xmlns:a="http://schemas.openxmlformats.org/drawingml/2006/main">
-              <a:ext uri="{FF2B5EF4-FFF2-40B4-BE49-F238E27FC236}">
-                <a16:creationId xmlns:a16="http://schemas.microsoft.com/office/drawing/2014/main" id="{47A9A4E0-4A33-4565-8467-3E1838E9A1DE}"/>
-              </a:ext>
-            </a:extLst>
-          </p:cNvPr>
-          <p:cNvGraphicFramePr/>
-          <p:nvPr/>
-        </p:nvGraphicFramePr>
-        <p:xfrm>
-          <a:off xmlns:a="http://schemas.openxmlformats.org/drawingml/2006/main" x="609600" y="4543425"/>
-          <a:ext xmlns:a="http://schemas.openxmlformats.org/drawingml/2006/main" cx="5334000" cy="1695450"/>
-        </p:xfrm>
-        <a:graphic xmlns:a="http://schemas.openxmlformats.org/drawingml/2006/main">
-          <a:graphicData uri="http://schemas.openxmlformats.org/drawingml/2006/chart">
-            <c:chart xmlns:r="http://schemas.openxmlformats.org/officeDocument/2006/relationships" xmlns:c="http://schemas.openxmlformats.org/drawingml/2006/chart" r:id="R6361ebd7bf7941e9"/>
-          </a:graphicData>
-        </a:graphic>
-      </p:graphicFrame>
       <p:sp>
         <p:nvSpPr>
           <p:cNvPr id="6" name="cv-winner">
@@ -9076,6 +9205,7 @@
           </a:lstStyle>
           <a:p xmlns:a="http://schemas.openxmlformats.org/drawingml/2006/main">
             <a:pPr algn="l">
+              <a:buNone/>
               <a:defRPr sz="2325" b="1">
                 <a:solidFill>
                   <a:srgbClr val="087D9A"/>
@@ -9145,6 +9275,7 @@
           </a:lstStyle>
           <a:p xmlns:a="http://schemas.openxmlformats.org/drawingml/2006/main">
             <a:pPr algn="l">
+              <a:buNone/>
               <a:defRPr sz="1950" b="0">
                 <a:solidFill>
                   <a:srgbClr val="102238"/>
@@ -9168,6 +9299,28 @@
           </a:p>
         </p:txBody>
       </p:sp>
+      <p:graphicFrame>
+        <p:nvGraphicFramePr>
+          <p:cNvPr id="9" name="Chart">
+            <a:extLst xmlns:a="http://schemas.openxmlformats.org/drawingml/2006/main">
+              <a:ext uri="{FF2B5EF4-FFF2-40B4-BE49-F238E27FC236}">
+                <a16:creationId xmlns:a16="http://schemas.microsoft.com/office/drawing/2014/main" id="{F3389745-748B-4A20-A565-A15FA72522B7}"/>
+              </a:ext>
+            </a:extLst>
+          </p:cNvPr>
+          <p:cNvGraphicFramePr/>
+          <p:nvPr/>
+        </p:nvGraphicFramePr>
+        <p:xfrm>
+          <a:off xmlns:a="http://schemas.openxmlformats.org/drawingml/2006/main" x="609600" y="4543425"/>
+          <a:ext xmlns:a="http://schemas.openxmlformats.org/drawingml/2006/main" cx="5334000" cy="1695450"/>
+        </p:xfrm>
+        <a:graphic xmlns:a="http://schemas.openxmlformats.org/drawingml/2006/main">
+          <a:graphicData uri="http://schemas.openxmlformats.org/drawingml/2006/chart">
+            <c:chart xmlns:r="http://schemas.openxmlformats.org/officeDocument/2006/relationships" xmlns:c="http://schemas.openxmlformats.org/drawingml/2006/chart" r:id="Rd22778b3ff914f05"/>
+          </a:graphicData>
+        </a:graphic>
+      </p:graphicFrame>
     </p:spTree>
     <p:extLst>
       <p:ext uri="{BB962C8B-B14F-4D97-AF65-F5344CB8AC3E}">
@@ -9243,6 +9396,7 @@
           </a:lstStyle>
           <a:p xmlns:a="http://schemas.openxmlformats.org/drawingml/2006/main">
             <a:pPr algn="l">
+              <a:buNone/>
               <a:defRPr sz="3300" b="1">
                 <a:solidFill>
                   <a:srgbClr val="102238"/>
@@ -9312,6 +9466,7 @@
           </a:lstStyle>
           <a:p xmlns:a="http://schemas.openxmlformats.org/drawingml/2006/main">
             <a:pPr algn="l">
+              <a:buNone/>
               <a:defRPr sz="1200" b="0">
                 <a:solidFill>
                   <a:srgbClr val="526579"/>
@@ -9381,6 +9536,7 @@
           </a:lstStyle>
           <a:p xmlns:a="http://schemas.openxmlformats.org/drawingml/2006/main">
             <a:pPr algn="r">
+              <a:buNone/>
               <a:defRPr sz="1200" b="0">
                 <a:solidFill>
                   <a:srgbClr val="526579"/>
@@ -9409,7 +9565,7 @@
           <p:cNvPr id="4" name="">
             <a:extLst xmlns:a="http://schemas.openxmlformats.org/drawingml/2006/main">
               <a:ext uri="{FF2B5EF4-FFF2-40B4-BE49-F238E27FC236}">
-                <a16:creationId xmlns:a16="http://schemas.microsoft.com/office/drawing/2014/main" id="{91555EBE-2DF1-4927-939C-00A8D5E2FCE8}"/>
+                <a16:creationId xmlns:a16="http://schemas.microsoft.com/office/drawing/2014/main" id="{52734106-6537-45FC-AF6A-51F216281898}"/>
               </a:ext>
             </a:extLst>
           </p:cNvPr>
@@ -10022,28 +10178,6 @@
           </a:graphicData>
         </a:graphic>
       </p:graphicFrame>
-      <p:graphicFrame>
-        <p:nvGraphicFramePr>
-          <p:cNvPr id="5" name="Chart">
-            <a:extLst xmlns:a="http://schemas.openxmlformats.org/drawingml/2006/main">
-              <a:ext uri="{FF2B5EF4-FFF2-40B4-BE49-F238E27FC236}">
-                <a16:creationId xmlns:a16="http://schemas.microsoft.com/office/drawing/2014/main" id="{CF1F5DFD-813A-4417-BFA4-29CB2A4D1B4F}"/>
-              </a:ext>
-            </a:extLst>
-          </p:cNvPr>
-          <p:cNvGraphicFramePr/>
-          <p:nvPr/>
-        </p:nvGraphicFramePr>
-        <p:xfrm>
-          <a:off xmlns:a="http://schemas.openxmlformats.org/drawingml/2006/main" x="7429500" y="1657350"/>
-          <a:ext xmlns:a="http://schemas.openxmlformats.org/drawingml/2006/main" cx="4143375" cy="3000375"/>
-        </p:xfrm>
-        <a:graphic xmlns:a="http://schemas.openxmlformats.org/drawingml/2006/main">
-          <a:graphicData uri="http://schemas.openxmlformats.org/drawingml/2006/chart">
-            <c:chart xmlns:r="http://schemas.openxmlformats.org/officeDocument/2006/relationships" xmlns:c="http://schemas.openxmlformats.org/drawingml/2006/chart" r:id="R9b3ef7b697634468"/>
-          </a:graphicData>
-        </a:graphic>
-      </p:graphicFrame>
       <p:sp>
         <p:nvSpPr>
           <p:cNvPr id="6" name="subgroup-support">
@@ -10090,6 +10224,7 @@
           </a:lstStyle>
           <a:p xmlns:a="http://schemas.openxmlformats.org/drawingml/2006/main">
             <a:pPr algn="l">
+              <a:buNone/>
               <a:defRPr sz="1875" b="0">
                 <a:solidFill>
                   <a:srgbClr val="526579"/>
@@ -10113,6 +10248,7 @@
           </a:p>
           <a:p xmlns:a="http://schemas.openxmlformats.org/drawingml/2006/main">
             <a:pPr algn="l">
+              <a:buNone/>
               <a:defRPr sz="1875" b="0">
                 <a:solidFill>
                   <a:srgbClr val="526579"/>
@@ -10182,6 +10318,7 @@
           </a:lstStyle>
           <a:p xmlns:a="http://schemas.openxmlformats.org/drawingml/2006/main">
             <a:pPr algn="l">
+              <a:buNone/>
               <a:defRPr sz="1800" b="0">
                 <a:solidFill>
                   <a:srgbClr val="102238"/>
@@ -10205,6 +10342,7 @@
           </a:p>
           <a:p xmlns:a="http://schemas.openxmlformats.org/drawingml/2006/main">
             <a:pPr algn="l">
+              <a:buNone/>
               <a:defRPr sz="1800" b="0">
                 <a:solidFill>
                   <a:srgbClr val="102238"/>
@@ -10228,6 +10366,28 @@
           </a:p>
         </p:txBody>
       </p:sp>
+      <p:graphicFrame>
+        <p:nvGraphicFramePr>
+          <p:cNvPr id="9" name="Chart">
+            <a:extLst xmlns:a="http://schemas.openxmlformats.org/drawingml/2006/main">
+              <a:ext uri="{FF2B5EF4-FFF2-40B4-BE49-F238E27FC236}">
+                <a16:creationId xmlns:a16="http://schemas.microsoft.com/office/drawing/2014/main" id="{99A72073-AE60-43F9-8F34-19A011549F74}"/>
+              </a:ext>
+            </a:extLst>
+          </p:cNvPr>
+          <p:cNvGraphicFramePr/>
+          <p:nvPr/>
+        </p:nvGraphicFramePr>
+        <p:xfrm>
+          <a:off xmlns:a="http://schemas.openxmlformats.org/drawingml/2006/main" x="7429500" y="1657350"/>
+          <a:ext xmlns:a="http://schemas.openxmlformats.org/drawingml/2006/main" cx="4143375" cy="3000375"/>
+        </p:xfrm>
+        <a:graphic xmlns:a="http://schemas.openxmlformats.org/drawingml/2006/main">
+          <a:graphicData uri="http://schemas.openxmlformats.org/drawingml/2006/chart">
+            <c:chart xmlns:r="http://schemas.openxmlformats.org/officeDocument/2006/relationships" xmlns:c="http://schemas.openxmlformats.org/drawingml/2006/chart" r:id="Rd99e967226ef431e"/>
+          </a:graphicData>
+        </a:graphic>
+      </p:graphicFrame>
     </p:spTree>
     <p:extLst>
       <p:ext uri="{BB962C8B-B14F-4D97-AF65-F5344CB8AC3E}">
@@ -10303,6 +10463,7 @@
           </a:lstStyle>
           <a:p xmlns:a="http://schemas.openxmlformats.org/drawingml/2006/main">
             <a:pPr algn="l">
+              <a:buNone/>
               <a:defRPr sz="3300" b="1">
                 <a:solidFill>
                   <a:srgbClr val="102238"/>
@@ -10372,6 +10533,7 @@
           </a:lstStyle>
           <a:p xmlns:a="http://schemas.openxmlformats.org/drawingml/2006/main">
             <a:pPr algn="l">
+              <a:buNone/>
               <a:defRPr sz="1200" b="0">
                 <a:solidFill>
                   <a:srgbClr val="526579"/>
@@ -10441,6 +10603,7 @@
           </a:lstStyle>
           <a:p xmlns:a="http://schemas.openxmlformats.org/drawingml/2006/main">
             <a:pPr algn="r">
+              <a:buNone/>
               <a:defRPr sz="1200" b="0">
                 <a:solidFill>
                   <a:srgbClr val="526579"/>
@@ -10510,6 +10673,7 @@
           </a:lstStyle>
           <a:p xmlns:a="http://schemas.openxmlformats.org/drawingml/2006/main">
             <a:pPr algn="l">
+              <a:buNone/>
               <a:defRPr sz="2625" b="1">
                 <a:solidFill>
                   <a:srgbClr val="087D9A"/>
@@ -10579,6 +10743,7 @@
           </a:lstStyle>
           <a:p xmlns:a="http://schemas.openxmlformats.org/drawingml/2006/main">
             <a:pPr algn="l">
+              <a:buNone/>
               <a:defRPr sz="2025" b="0">
                 <a:solidFill>
                   <a:srgbClr val="102238"/>
@@ -10602,6 +10767,7 @@
           </a:p>
           <a:p xmlns:a="http://schemas.openxmlformats.org/drawingml/2006/main">
             <a:pPr algn="l">
+              <a:buNone/>
               <a:defRPr sz="2025" b="0">
                 <a:solidFill>
                   <a:srgbClr val="102238"/>
@@ -10625,6 +10791,7 @@
           </a:p>
           <a:p xmlns:a="http://schemas.openxmlformats.org/drawingml/2006/main">
             <a:pPr algn="l">
+              <a:buNone/>
               <a:defRPr sz="2025" b="0">
                 <a:solidFill>
                   <a:srgbClr val="102238"/>
@@ -10648,6 +10815,7 @@
           </a:p>
           <a:p xmlns:a="http://schemas.openxmlformats.org/drawingml/2006/main">
             <a:pPr algn="l">
+              <a:buNone/>
               <a:defRPr sz="2025" b="0">
                 <a:solidFill>
                   <a:srgbClr val="102238"/>
@@ -10717,6 +10885,7 @@
           </a:lstStyle>
           <a:p xmlns:a="http://schemas.openxmlformats.org/drawingml/2006/main">
             <a:pPr algn="l">
+              <a:buNone/>
               <a:defRPr sz="2025" b="0">
                 <a:solidFill>
                   <a:srgbClr val="102238"/>
@@ -10740,6 +10909,7 @@
           </a:p>
           <a:p xmlns:a="http://schemas.openxmlformats.org/drawingml/2006/main">
             <a:pPr algn="l">
+              <a:buNone/>
               <a:defRPr sz="2025" b="0">
                 <a:solidFill>
                   <a:srgbClr val="102238"/>
@@ -10768,6 +10938,7 @@
           </a:p>
           <a:p xmlns:a="http://schemas.openxmlformats.org/drawingml/2006/main">
             <a:pPr algn="l">
+              <a:buNone/>
               <a:defRPr sz="2025" b="0">
                 <a:solidFill>
                   <a:srgbClr val="102238"/>
@@ -10791,6 +10962,7 @@
           </a:p>
           <a:p xmlns:a="http://schemas.openxmlformats.org/drawingml/2006/main">
             <a:pPr algn="l">
+              <a:buNone/>
               <a:defRPr sz="2025" b="0">
                 <a:solidFill>
                   <a:srgbClr val="102238"/>
@@ -10860,6 +11032,7 @@
           </a:lstStyle>
           <a:p xmlns:a="http://schemas.openxmlformats.org/drawingml/2006/main">
             <a:pPr algn="l">
+              <a:buNone/>
               <a:defRPr sz="1950" b="0">
                 <a:solidFill>
                   <a:srgbClr val="526579"/>
@@ -10878,11 +11051,12 @@
                 <a:ea typeface="Arial"/>
                 <a:cs typeface="Arial"/>
               </a:rPr>
-              <a:t>AI demonstration; simulated team roles:</a:t>
+              <a:t>Project areas: Nikita, data collection. Bakytzhan, modeling and analysis.</a:t>
             </a:r>
           </a:p>
           <a:p xmlns:a="http://schemas.openxmlformats.org/drawingml/2006/main">
             <a:pPr algn="l">
+              <a:buNone/>
               <a:defRPr sz="1950" b="0">
                 <a:solidFill>
                   <a:srgbClr val="526579"/>
@@ -10901,7 +11075,7 @@
                 <a:ea typeface="Arial"/>
                 <a:cs typeface="Arial"/>
               </a:rPr>
-              <a:t>Nikita: data and collection. Bakyt: models, analysis and slides.</a:t>
+              <a:t>AI assistance: OpenAI Codex.</a:t>
             </a:r>
           </a:p>
         </p:txBody>

</xml_diff>